<commit_message>
fixed typo in the PPT file
</commit_message>
<xml_diff>
--- a/07/07_eloadas_HTML5_CSS_responsive_design.pptx
+++ b/07/07_eloadas_HTML5_CSS_responsive_design.pptx
@@ -213,7 +213,7 @@
           <a:p>
             <a:fld id="{4C482E4E-5CEC-44A9-BF2B-512FB3B5604F}" type="datetimeFigureOut">
               <a:rPr lang="en-US" smtClean="0"/>
-              <a:t>1/12/2026</a:t>
+              <a:t>3/29/2026</a:t>
             </a:fld>
             <a:endParaRPr lang="en-US"/>
           </a:p>
@@ -5084,7 +5084,7 @@
             </a:r>
             <a:r>
               <a:rPr lang="hu-HU" dirty="0"/>
-              <a:t> felépített nem szemantikus HTML oldal, a bal oldalon pedig egy </a:t>
+              <a:t> felépített nem szemantikus HTML oldal, a jobb oldalon pedig egy </a:t>
             </a:r>
             <a:r>
               <a:rPr lang="hu-HU" b="1" dirty="0"/>
@@ -5170,15 +5170,13 @@
               <a:rPr lang="en-US" dirty="0"/>
               <a:t>.</a:t>
             </a:r>
-            <a:endParaRPr lang="hu-HU" dirty="0"/>
-          </a:p>
-          <a:p>
-            <a:endParaRPr lang="hu-HU" dirty="0"/>
-          </a:p>
-          <a:p>
+            <a:r>
+              <a:rPr lang="hu-HU"/>
+              <a:t> Látható</a:t>
+            </a:r>
             <a:r>
               <a:rPr lang="hu-HU" dirty="0"/>
-              <a:t>Látható, hogy a blog címe a </a:t>
+              <a:t>, hogy a blog címe a </a:t>
             </a:r>
             <a:r>
               <a:rPr lang="hu-HU" b="1" dirty="0" err="1"/>
@@ -7568,7 +7566,7 @@
           <a:p>
             <a:fld id="{E80C50CD-E178-4744-9B35-B2F624D6C5E9}" type="datetimeFigureOut">
               <a:rPr lang="en-US" smtClean="0"/>
-              <a:t>1/12/2026</a:t>
+              <a:t>3/29/2026</a:t>
             </a:fld>
             <a:endParaRPr lang="en-US"/>
           </a:p>
@@ -7766,7 +7764,7 @@
           <a:p>
             <a:fld id="{E80C50CD-E178-4744-9B35-B2F624D6C5E9}" type="datetimeFigureOut">
               <a:rPr lang="en-US" smtClean="0"/>
-              <a:t>1/12/2026</a:t>
+              <a:t>3/29/2026</a:t>
             </a:fld>
             <a:endParaRPr lang="en-US"/>
           </a:p>
@@ -7974,7 +7972,7 @@
           <a:p>
             <a:fld id="{E80C50CD-E178-4744-9B35-B2F624D6C5E9}" type="datetimeFigureOut">
               <a:rPr lang="en-US" smtClean="0"/>
-              <a:t>1/12/2026</a:t>
+              <a:t>3/29/2026</a:t>
             </a:fld>
             <a:endParaRPr lang="en-US"/>
           </a:p>
@@ -8224,7 +8222,7 @@
           <a:p>
             <a:fld id="{E80C50CD-E178-4744-9B35-B2F624D6C5E9}" type="datetimeFigureOut">
               <a:rPr lang="en-US" smtClean="0"/>
-              <a:t>1/12/2026</a:t>
+              <a:t>3/29/2026</a:t>
             </a:fld>
             <a:endParaRPr lang="en-US"/>
           </a:p>
@@ -8503,7 +8501,7 @@
           <a:p>
             <a:fld id="{E80C50CD-E178-4744-9B35-B2F624D6C5E9}" type="datetimeFigureOut">
               <a:rPr lang="en-US" smtClean="0"/>
-              <a:t>1/12/2026</a:t>
+              <a:t>3/29/2026</a:t>
             </a:fld>
             <a:endParaRPr lang="en-US"/>
           </a:p>
@@ -8820,7 +8818,7 @@
           <a:p>
             <a:fld id="{E80C50CD-E178-4744-9B35-B2F624D6C5E9}" type="datetimeFigureOut">
               <a:rPr lang="en-US" smtClean="0"/>
-              <a:t>1/12/2026</a:t>
+              <a:t>3/29/2026</a:t>
             </a:fld>
             <a:endParaRPr lang="en-US"/>
           </a:p>
@@ -9236,7 +9234,7 @@
           <a:p>
             <a:fld id="{E80C50CD-E178-4744-9B35-B2F624D6C5E9}" type="datetimeFigureOut">
               <a:rPr lang="en-US" smtClean="0"/>
-              <a:t>1/12/2026</a:t>
+              <a:t>3/29/2026</a:t>
             </a:fld>
             <a:endParaRPr lang="en-US"/>
           </a:p>
@@ -9377,7 +9375,7 @@
           <a:p>
             <a:fld id="{E80C50CD-E178-4744-9B35-B2F624D6C5E9}" type="datetimeFigureOut">
               <a:rPr lang="en-US" smtClean="0"/>
-              <a:t>1/12/2026</a:t>
+              <a:t>3/29/2026</a:t>
             </a:fld>
             <a:endParaRPr lang="en-US"/>
           </a:p>
@@ -9490,7 +9488,7 @@
           <a:p>
             <a:fld id="{E80C50CD-E178-4744-9B35-B2F624D6C5E9}" type="datetimeFigureOut">
               <a:rPr lang="en-US" smtClean="0"/>
-              <a:t>1/12/2026</a:t>
+              <a:t>3/29/2026</a:t>
             </a:fld>
             <a:endParaRPr lang="en-US"/>
           </a:p>
@@ -9807,7 +9805,7 @@
           <a:p>
             <a:fld id="{E80C50CD-E178-4744-9B35-B2F624D6C5E9}" type="datetimeFigureOut">
               <a:rPr lang="en-US" smtClean="0"/>
-              <a:t>1/12/2026</a:t>
+              <a:t>3/29/2026</a:t>
             </a:fld>
             <a:endParaRPr lang="en-US"/>
           </a:p>
@@ -10099,7 +10097,7 @@
           <a:p>
             <a:fld id="{E80C50CD-E178-4744-9B35-B2F624D6C5E9}" type="datetimeFigureOut">
               <a:rPr lang="en-US" smtClean="0"/>
-              <a:t>1/12/2026</a:t>
+              <a:t>3/29/2026</a:t>
             </a:fld>
             <a:endParaRPr lang="en-US"/>
           </a:p>
@@ -10339,7 +10337,7 @@
             <a:fld id="{E80C50CD-E178-4744-9B35-B2F624D6C5E9}" type="datetimeFigureOut">
               <a:rPr lang="en-US" smtClean="0"/>
               <a:pPr/>
-              <a:t>1/12/2026</a:t>
+              <a:t>3/29/2026</a:t>
             </a:fld>
             <a:endParaRPr lang="en-US"/>
           </a:p>

</xml_diff>

<commit_message>
updated PPT and PDF files for 07 presentation
</commit_message>
<xml_diff>
--- a/07/07_eloadas_HTML5_CSS_responsive_design.pptx
+++ b/07/07_eloadas_HTML5_CSS_responsive_design.pptx
@@ -213,7 +213,7 @@
           <a:p>
             <a:fld id="{4C482E4E-5CEC-44A9-BF2B-512FB3B5604F}" type="datetimeFigureOut">
               <a:rPr lang="en-US" smtClean="0"/>
-              <a:t>3/29/2026</a:t>
+              <a:t>4/4/2026</a:t>
             </a:fld>
             <a:endParaRPr lang="en-US"/>
           </a:p>
@@ -1700,6 +1700,292 @@
               <a:rPr lang="en-US" dirty="0"/>
               <a:t>.</a:t>
             </a:r>
+            <a:endParaRPr lang="hu-HU" dirty="0"/>
+          </a:p>
+          <a:p>
+            <a:endParaRPr lang="hu-HU" dirty="0"/>
+          </a:p>
+          <a:p>
+            <a:r>
+              <a:rPr lang="en-US" dirty="0"/>
+              <a:t>A </a:t>
+            </a:r>
+            <a:r>
+              <a:rPr lang="en-US" b="1" dirty="0"/>
+              <a:t>viewport</a:t>
+            </a:r>
+            <a:r>
+              <a:rPr lang="en-US" dirty="0"/>
+              <a:t> meta tag </a:t>
+            </a:r>
+            <a:r>
+              <a:rPr lang="en-US" dirty="0" err="1"/>
+              <a:t>azt</a:t>
+            </a:r>
+            <a:r>
+              <a:rPr lang="en-US" dirty="0"/>
+              <a:t> </a:t>
+            </a:r>
+            <a:r>
+              <a:rPr lang="en-US" dirty="0" err="1"/>
+              <a:t>mondja</a:t>
+            </a:r>
+            <a:r>
+              <a:rPr lang="en-US" dirty="0"/>
+              <a:t> meg a </a:t>
+            </a:r>
+            <a:r>
+              <a:rPr lang="en-US" dirty="0" err="1"/>
+              <a:t>böngészőnek</a:t>
+            </a:r>
+            <a:r>
+              <a:rPr lang="en-US" dirty="0"/>
+              <a:t>, </a:t>
+            </a:r>
+            <a:r>
+              <a:rPr lang="en-US" dirty="0" err="1"/>
+              <a:t>hogyan</a:t>
+            </a:r>
+            <a:r>
+              <a:rPr lang="en-US" dirty="0"/>
+              <a:t> </a:t>
+            </a:r>
+            <a:r>
+              <a:rPr lang="en-US" dirty="0" err="1"/>
+              <a:t>méretezze</a:t>
+            </a:r>
+            <a:r>
+              <a:rPr lang="en-US" dirty="0"/>
+              <a:t> és </a:t>
+            </a:r>
+            <a:r>
+              <a:rPr lang="en-US" dirty="0" err="1"/>
+              <a:t>jelenítse</a:t>
+            </a:r>
+            <a:r>
+              <a:rPr lang="en-US" dirty="0"/>
+              <a:t> meg </a:t>
+            </a:r>
+            <a:r>
+              <a:rPr lang="en-US" dirty="0" err="1"/>
+              <a:t>az</a:t>
+            </a:r>
+            <a:r>
+              <a:rPr lang="en-US" dirty="0"/>
+              <a:t> </a:t>
+            </a:r>
+            <a:r>
+              <a:rPr lang="en-US" dirty="0" err="1"/>
+              <a:t>oldalt</a:t>
+            </a:r>
+            <a:r>
+              <a:rPr lang="en-US" dirty="0"/>
+              <a:t> </a:t>
+            </a:r>
+            <a:r>
+              <a:rPr lang="en-US" dirty="0" err="1"/>
+              <a:t>különböző</a:t>
+            </a:r>
+            <a:r>
+              <a:rPr lang="en-US" dirty="0"/>
+              <a:t> </a:t>
+            </a:r>
+            <a:r>
+              <a:rPr lang="en-US" dirty="0" err="1"/>
+              <a:t>eszközökön</a:t>
+            </a:r>
+            <a:r>
+              <a:rPr lang="en-US" dirty="0"/>
+              <a:t>. Ha </a:t>
+            </a:r>
+            <a:r>
+              <a:rPr lang="en-US" dirty="0" err="1"/>
+              <a:t>megadjuk</a:t>
+            </a:r>
+            <a:r>
+              <a:rPr lang="en-US" dirty="0"/>
+              <a:t>, </a:t>
+            </a:r>
+            <a:r>
+              <a:rPr lang="en-US" dirty="0" err="1"/>
+              <a:t>hogy</a:t>
+            </a:r>
+            <a:r>
+              <a:rPr lang="en-US" dirty="0"/>
+              <a:t> a </a:t>
+            </a:r>
+            <a:r>
+              <a:rPr lang="en-US" dirty="0" err="1"/>
+              <a:t>szélesség</a:t>
+            </a:r>
+            <a:r>
+              <a:rPr lang="en-US" dirty="0"/>
+              <a:t> </a:t>
+            </a:r>
+            <a:r>
+              <a:rPr lang="en-US" dirty="0" err="1"/>
+              <a:t>egyezzen</a:t>
+            </a:r>
+            <a:r>
+              <a:rPr lang="en-US" dirty="0"/>
+              <a:t> meg </a:t>
+            </a:r>
+            <a:r>
+              <a:rPr lang="en-US" dirty="0" err="1"/>
+              <a:t>az</a:t>
+            </a:r>
+            <a:r>
+              <a:rPr lang="en-US" dirty="0"/>
+              <a:t> </a:t>
+            </a:r>
+            <a:r>
+              <a:rPr lang="en-US" dirty="0" err="1"/>
+              <a:t>eszköz</a:t>
+            </a:r>
+            <a:r>
+              <a:rPr lang="en-US" dirty="0"/>
+              <a:t> </a:t>
+            </a:r>
+            <a:r>
+              <a:rPr lang="en-US" dirty="0" err="1"/>
+              <a:t>szélességével</a:t>
+            </a:r>
+            <a:r>
+              <a:rPr lang="en-US" dirty="0"/>
+              <a:t>, </a:t>
+            </a:r>
+            <a:r>
+              <a:rPr lang="en-US" dirty="0" err="1"/>
+              <a:t>akkor</a:t>
+            </a:r>
+            <a:r>
+              <a:rPr lang="en-US" dirty="0"/>
+              <a:t> a layout </a:t>
+            </a:r>
+            <a:r>
+              <a:rPr lang="en-US" dirty="0" err="1"/>
+              <a:t>helyesen</a:t>
+            </a:r>
+            <a:r>
+              <a:rPr lang="en-US" dirty="0"/>
+              <a:t> </a:t>
+            </a:r>
+            <a:r>
+              <a:rPr lang="en-US" dirty="0" err="1"/>
+              <a:t>alkalmazkodik</a:t>
+            </a:r>
+            <a:r>
+              <a:rPr lang="en-US" dirty="0"/>
+              <a:t> </a:t>
+            </a:r>
+            <a:r>
+              <a:rPr lang="en-US" dirty="0" err="1"/>
+              <a:t>mobilon</a:t>
+            </a:r>
+            <a:r>
+              <a:rPr lang="en-US" dirty="0"/>
+              <a:t> is. </a:t>
+            </a:r>
+            <a:r>
+              <a:rPr lang="en-US" dirty="0" err="1"/>
+              <a:t>Enélkül</a:t>
+            </a:r>
+            <a:r>
+              <a:rPr lang="en-US" dirty="0"/>
+              <a:t> a </a:t>
+            </a:r>
+            <a:r>
+              <a:rPr lang="en-US" dirty="0" err="1"/>
+              <a:t>böngésző</a:t>
+            </a:r>
+            <a:r>
+              <a:rPr lang="en-US" dirty="0"/>
+              <a:t> „</a:t>
+            </a:r>
+            <a:r>
+              <a:rPr lang="en-US" dirty="0" err="1"/>
+              <a:t>lekicsinyített</a:t>
+            </a:r>
+            <a:r>
+              <a:rPr lang="en-US" dirty="0"/>
+              <a:t> desktop </a:t>
+            </a:r>
+            <a:r>
+              <a:rPr lang="en-US" dirty="0" err="1"/>
+              <a:t>oldalként</a:t>
+            </a:r>
+            <a:r>
+              <a:rPr lang="en-US" dirty="0"/>
+              <a:t>” </a:t>
+            </a:r>
+            <a:r>
+              <a:rPr lang="en-US" dirty="0" err="1"/>
+              <a:t>jeleníti</a:t>
+            </a:r>
+            <a:r>
+              <a:rPr lang="en-US" dirty="0"/>
+              <a:t> meg </a:t>
+            </a:r>
+            <a:r>
+              <a:rPr lang="en-US" dirty="0" err="1"/>
+              <a:t>az</a:t>
+            </a:r>
+            <a:r>
+              <a:rPr lang="en-US" dirty="0"/>
+              <a:t> </a:t>
+            </a:r>
+            <a:r>
+              <a:rPr lang="en-US" dirty="0" err="1"/>
+              <a:t>oldalt</a:t>
+            </a:r>
+            <a:r>
+              <a:rPr lang="en-US" dirty="0"/>
+              <a:t>, </a:t>
+            </a:r>
+            <a:r>
+              <a:rPr lang="en-US" dirty="0" err="1"/>
+              <a:t>ami</a:t>
+            </a:r>
+            <a:r>
+              <a:rPr lang="en-US" dirty="0"/>
+              <a:t> </a:t>
+            </a:r>
+            <a:r>
+              <a:rPr lang="en-US" dirty="0" err="1"/>
+              <a:t>rossz</a:t>
+            </a:r>
+            <a:r>
+              <a:rPr lang="en-US" dirty="0"/>
+              <a:t> </a:t>
+            </a:r>
+            <a:r>
+              <a:rPr lang="en-US" dirty="0" err="1"/>
+              <a:t>felhasználói</a:t>
+            </a:r>
+            <a:r>
+              <a:rPr lang="en-US" dirty="0"/>
+              <a:t> </a:t>
+            </a:r>
+            <a:r>
+              <a:rPr lang="en-US" dirty="0" err="1"/>
+              <a:t>élményt</a:t>
+            </a:r>
+            <a:r>
+              <a:rPr lang="en-US" dirty="0"/>
+              <a:t> </a:t>
+            </a:r>
+            <a:r>
+              <a:rPr lang="en-US" dirty="0" err="1"/>
+              <a:t>eredményez</a:t>
+            </a:r>
+            <a:r>
+              <a:rPr lang="en-US" dirty="0"/>
+              <a:t>.</a:t>
+            </a:r>
+            <a:endParaRPr lang="hu-HU" dirty="0"/>
+          </a:p>
+          <a:p>
+            <a:endParaRPr lang="hu-HU" dirty="0"/>
           </a:p>
         </p:txBody>
       </p:sp>
@@ -2089,9 +2375,6 @@
             <a:endParaRPr lang="hu-HU" dirty="0"/>
           </a:p>
           <a:p>
-            <a:endParaRPr lang="hu-HU" dirty="0"/>
-          </a:p>
-          <a:p>
             <a:r>
               <a:rPr lang="hu-HU" dirty="0"/>
               <a:t>A </a:t>
@@ -2124,6 +2407,212 @@
               <a:rPr lang="hu-HU" dirty="0"/>
               <a:t> CSS stílus elemen.</a:t>
             </a:r>
+          </a:p>
+          <a:p>
+            <a:endParaRPr lang="hu-HU" dirty="0"/>
+          </a:p>
+          <a:p>
+            <a:r>
+              <a:rPr lang="en-US" dirty="0"/>
+              <a:t>A </a:t>
+            </a:r>
+            <a:r>
+              <a:rPr lang="en-US" b="1" dirty="0"/>
+              <a:t>viewport</a:t>
+            </a:r>
+            <a:r>
+              <a:rPr lang="en-US" dirty="0"/>
+              <a:t> meta tag </a:t>
+            </a:r>
+            <a:r>
+              <a:rPr lang="en-US" dirty="0" err="1"/>
+              <a:t>azt</a:t>
+            </a:r>
+            <a:r>
+              <a:rPr lang="en-US" dirty="0"/>
+              <a:t> </a:t>
+            </a:r>
+            <a:r>
+              <a:rPr lang="en-US" dirty="0" err="1"/>
+              <a:t>mondja</a:t>
+            </a:r>
+            <a:r>
+              <a:rPr lang="en-US" dirty="0"/>
+              <a:t> meg a </a:t>
+            </a:r>
+            <a:r>
+              <a:rPr lang="en-US" dirty="0" err="1"/>
+              <a:t>böngészőnek</a:t>
+            </a:r>
+            <a:r>
+              <a:rPr lang="en-US" dirty="0"/>
+              <a:t>, </a:t>
+            </a:r>
+            <a:r>
+              <a:rPr lang="en-US" dirty="0" err="1"/>
+              <a:t>hogyan</a:t>
+            </a:r>
+            <a:r>
+              <a:rPr lang="en-US" dirty="0"/>
+              <a:t> </a:t>
+            </a:r>
+            <a:r>
+              <a:rPr lang="en-US" dirty="0" err="1"/>
+              <a:t>méretezze</a:t>
+            </a:r>
+            <a:r>
+              <a:rPr lang="en-US" dirty="0"/>
+              <a:t> és </a:t>
+            </a:r>
+            <a:r>
+              <a:rPr lang="en-US" dirty="0" err="1"/>
+              <a:t>jelenítse</a:t>
+            </a:r>
+            <a:r>
+              <a:rPr lang="en-US" dirty="0"/>
+              <a:t> meg </a:t>
+            </a:r>
+            <a:r>
+              <a:rPr lang="en-US" dirty="0" err="1"/>
+              <a:t>az</a:t>
+            </a:r>
+            <a:r>
+              <a:rPr lang="en-US" dirty="0"/>
+              <a:t> </a:t>
+            </a:r>
+            <a:r>
+              <a:rPr lang="en-US" dirty="0" err="1"/>
+              <a:t>oldalt</a:t>
+            </a:r>
+            <a:r>
+              <a:rPr lang="en-US" dirty="0"/>
+              <a:t> </a:t>
+            </a:r>
+            <a:r>
+              <a:rPr lang="en-US" dirty="0" err="1"/>
+              <a:t>különböző</a:t>
+            </a:r>
+            <a:r>
+              <a:rPr lang="en-US" dirty="0"/>
+              <a:t> </a:t>
+            </a:r>
+            <a:r>
+              <a:rPr lang="en-US" dirty="0" err="1"/>
+              <a:t>eszközökön</a:t>
+            </a:r>
+            <a:r>
+              <a:rPr lang="hu-HU" dirty="0"/>
+              <a:t>:</a:t>
+            </a:r>
+          </a:p>
+          <a:p>
+            <a:endParaRPr lang="hu-HU" b="1" dirty="0"/>
+          </a:p>
+          <a:p>
+            <a:r>
+              <a:rPr lang="hu-HU" b="1" dirty="0"/>
+              <a:t>- </a:t>
+            </a:r>
+            <a:r>
+              <a:rPr lang="en-US" b="1" dirty="0"/>
+              <a:t>width=device-width</a:t>
+            </a:r>
+            <a:r>
+              <a:rPr lang="en-US" dirty="0"/>
+              <a:t> → a viewport </a:t>
+            </a:r>
+            <a:r>
+              <a:rPr lang="en-US" dirty="0" err="1"/>
+              <a:t>szélessége</a:t>
+            </a:r>
+            <a:r>
+              <a:rPr lang="en-US" dirty="0"/>
+              <a:t> </a:t>
+            </a:r>
+            <a:r>
+              <a:rPr lang="en-US" dirty="0" err="1"/>
+              <a:t>megegyezik</a:t>
+            </a:r>
+            <a:r>
+              <a:rPr lang="en-US" dirty="0"/>
+              <a:t> </a:t>
+            </a:r>
+            <a:r>
+              <a:rPr lang="en-US" dirty="0" err="1"/>
+              <a:t>az</a:t>
+            </a:r>
+            <a:r>
+              <a:rPr lang="en-US" dirty="0"/>
+              <a:t> </a:t>
+            </a:r>
+            <a:r>
+              <a:rPr lang="en-US" dirty="0" err="1"/>
+              <a:t>eszköz</a:t>
+            </a:r>
+            <a:r>
+              <a:rPr lang="en-US" dirty="0"/>
+              <a:t> </a:t>
+            </a:r>
+            <a:r>
+              <a:rPr lang="en-US" dirty="0" err="1"/>
+              <a:t>képernyőszélességével</a:t>
+            </a:r>
+            <a:endParaRPr lang="hu-HU" dirty="0"/>
+          </a:p>
+          <a:p>
+            <a:r>
+              <a:rPr lang="hu-HU" b="1" dirty="0"/>
+              <a:t>- </a:t>
+            </a:r>
+            <a:r>
+              <a:rPr lang="en-US" b="1" dirty="0"/>
+              <a:t>initial-scale=1.0</a:t>
+            </a:r>
+            <a:r>
+              <a:rPr lang="en-US" dirty="0"/>
+              <a:t> → </a:t>
+            </a:r>
+            <a:r>
+              <a:rPr lang="en-US" dirty="0" err="1"/>
+              <a:t>az</a:t>
+            </a:r>
+            <a:r>
+              <a:rPr lang="en-US" dirty="0"/>
+              <a:t> </a:t>
+            </a:r>
+            <a:r>
+              <a:rPr lang="en-US" dirty="0" err="1"/>
+              <a:t>oldal</a:t>
+            </a:r>
+            <a:r>
+              <a:rPr lang="en-US" dirty="0"/>
+              <a:t> </a:t>
+            </a:r>
+            <a:r>
+              <a:rPr lang="en-US" dirty="0" err="1"/>
+              <a:t>kezdeti</a:t>
+            </a:r>
+            <a:r>
+              <a:rPr lang="en-US" dirty="0"/>
+              <a:t> </a:t>
+            </a:r>
+            <a:r>
+              <a:rPr lang="en-US" dirty="0" err="1"/>
+              <a:t>nagyítása</a:t>
+            </a:r>
+            <a:r>
+              <a:rPr lang="en-US" dirty="0"/>
+              <a:t> 100% (</a:t>
+            </a:r>
+            <a:r>
+              <a:rPr lang="en-US" dirty="0" err="1"/>
+              <a:t>nincs</a:t>
+            </a:r>
+            <a:r>
+              <a:rPr lang="en-US" dirty="0"/>
+              <a:t> zoom)</a:t>
+            </a:r>
+            <a:endParaRPr lang="hu-HU" dirty="0"/>
           </a:p>
           <a:p>
             <a:endParaRPr lang="hu-HU" dirty="0"/>
@@ -7566,7 +8055,7 @@
           <a:p>
             <a:fld id="{E80C50CD-E178-4744-9B35-B2F624D6C5E9}" type="datetimeFigureOut">
               <a:rPr lang="en-US" smtClean="0"/>
-              <a:t>3/29/2026</a:t>
+              <a:t>4/4/2026</a:t>
             </a:fld>
             <a:endParaRPr lang="en-US"/>
           </a:p>
@@ -7764,7 +8253,7 @@
           <a:p>
             <a:fld id="{E80C50CD-E178-4744-9B35-B2F624D6C5E9}" type="datetimeFigureOut">
               <a:rPr lang="en-US" smtClean="0"/>
-              <a:t>3/29/2026</a:t>
+              <a:t>4/4/2026</a:t>
             </a:fld>
             <a:endParaRPr lang="en-US"/>
           </a:p>
@@ -7972,7 +8461,7 @@
           <a:p>
             <a:fld id="{E80C50CD-E178-4744-9B35-B2F624D6C5E9}" type="datetimeFigureOut">
               <a:rPr lang="en-US" smtClean="0"/>
-              <a:t>3/29/2026</a:t>
+              <a:t>4/4/2026</a:t>
             </a:fld>
             <a:endParaRPr lang="en-US"/>
           </a:p>
@@ -8222,7 +8711,7 @@
           <a:p>
             <a:fld id="{E80C50CD-E178-4744-9B35-B2F624D6C5E9}" type="datetimeFigureOut">
               <a:rPr lang="en-US" smtClean="0"/>
-              <a:t>3/29/2026</a:t>
+              <a:t>4/4/2026</a:t>
             </a:fld>
             <a:endParaRPr lang="en-US"/>
           </a:p>
@@ -8501,7 +8990,7 @@
           <a:p>
             <a:fld id="{E80C50CD-E178-4744-9B35-B2F624D6C5E9}" type="datetimeFigureOut">
               <a:rPr lang="en-US" smtClean="0"/>
-              <a:t>3/29/2026</a:t>
+              <a:t>4/4/2026</a:t>
             </a:fld>
             <a:endParaRPr lang="en-US"/>
           </a:p>
@@ -8818,7 +9307,7 @@
           <a:p>
             <a:fld id="{E80C50CD-E178-4744-9B35-B2F624D6C5E9}" type="datetimeFigureOut">
               <a:rPr lang="en-US" smtClean="0"/>
-              <a:t>3/29/2026</a:t>
+              <a:t>4/4/2026</a:t>
             </a:fld>
             <a:endParaRPr lang="en-US"/>
           </a:p>
@@ -9234,7 +9723,7 @@
           <a:p>
             <a:fld id="{E80C50CD-E178-4744-9B35-B2F624D6C5E9}" type="datetimeFigureOut">
               <a:rPr lang="en-US" smtClean="0"/>
-              <a:t>3/29/2026</a:t>
+              <a:t>4/4/2026</a:t>
             </a:fld>
             <a:endParaRPr lang="en-US"/>
           </a:p>
@@ -9375,7 +9864,7 @@
           <a:p>
             <a:fld id="{E80C50CD-E178-4744-9B35-B2F624D6C5E9}" type="datetimeFigureOut">
               <a:rPr lang="en-US" smtClean="0"/>
-              <a:t>3/29/2026</a:t>
+              <a:t>4/4/2026</a:t>
             </a:fld>
             <a:endParaRPr lang="en-US"/>
           </a:p>
@@ -9488,7 +9977,7 @@
           <a:p>
             <a:fld id="{E80C50CD-E178-4744-9B35-B2F624D6C5E9}" type="datetimeFigureOut">
               <a:rPr lang="en-US" smtClean="0"/>
-              <a:t>3/29/2026</a:t>
+              <a:t>4/4/2026</a:t>
             </a:fld>
             <a:endParaRPr lang="en-US"/>
           </a:p>
@@ -9805,7 +10294,7 @@
           <a:p>
             <a:fld id="{E80C50CD-E178-4744-9B35-B2F624D6C5E9}" type="datetimeFigureOut">
               <a:rPr lang="en-US" smtClean="0"/>
-              <a:t>3/29/2026</a:t>
+              <a:t>4/4/2026</a:t>
             </a:fld>
             <a:endParaRPr lang="en-US"/>
           </a:p>
@@ -10097,7 +10586,7 @@
           <a:p>
             <a:fld id="{E80C50CD-E178-4744-9B35-B2F624D6C5E9}" type="datetimeFigureOut">
               <a:rPr lang="en-US" smtClean="0"/>
-              <a:t>3/29/2026</a:t>
+              <a:t>4/4/2026</a:t>
             </a:fld>
             <a:endParaRPr lang="en-US"/>
           </a:p>
@@ -10337,7 +10826,7 @@
             <a:fld id="{E80C50CD-E178-4744-9B35-B2F624D6C5E9}" type="datetimeFigureOut">
               <a:rPr lang="en-US" smtClean="0"/>
               <a:pPr/>
-              <a:t>3/29/2026</a:t>
+              <a:t>4/4/2026</a:t>
             </a:fld>
             <a:endParaRPr lang="en-US"/>
           </a:p>
@@ -12455,8 +12944,8 @@
         </p:nvSpPr>
         <p:spPr bwMode="auto">
           <a:xfrm>
-            <a:off x="521208" y="2113334"/>
-            <a:ext cx="9791835" cy="3584379"/>
+            <a:off x="521208" y="1905498"/>
+            <a:ext cx="11149584" cy="4140429"/>
           </a:xfrm>
           <a:prstGeom prst="rect">
             <a:avLst/>
@@ -13199,7 +13688,87 @@
               </a:rPr>
               <a:t>: feltételhez kötött CSS szabályok</a:t>
             </a:r>
-            <a:endParaRPr kumimoji="0" lang="en-US" altLang="en-US" sz="2200" b="0" i="0" u="none" strike="noStrike" cap="none" normalizeH="0" baseline="0" dirty="0">
+          </a:p>
+          <a:p>
+            <a:pPr marL="0" lvl="0" indent="0" eaLnBrk="0" fontAlgn="base" hangingPunct="0">
+              <a:lnSpc>
+                <a:spcPct val="150000"/>
+              </a:lnSpc>
+              <a:spcBef>
+                <a:spcPct val="0"/>
+              </a:spcBef>
+              <a:spcAft>
+                <a:spcPct val="0"/>
+              </a:spcAft>
+              <a:buFontTx/>
+              <a:buChar char="•"/>
+            </a:pPr>
+            <a:r>
+              <a:rPr kumimoji="0" lang="hu-HU" altLang="en-US" sz="2200" b="0" i="0" u="none" strike="noStrike" cap="none" normalizeH="0" baseline="0" dirty="0">
+                <a:ln>
+                  <a:noFill/>
+                </a:ln>
+                <a:solidFill>
+                  <a:schemeClr val="tx1"/>
+                </a:solidFill>
+                <a:effectLst/>
+                <a:latin typeface="Arial" panose="020B0604020202020204" pitchFamily="34" charset="0"/>
+              </a:rPr>
+              <a:t> </a:t>
+            </a:r>
+            <a:r>
+              <a:rPr lang="en-US" sz="2400" b="1" dirty="0"/>
+              <a:t>Viewport</a:t>
+            </a:r>
+            <a:r>
+              <a:rPr lang="en-US" sz="2400" dirty="0"/>
+              <a:t> meta tag</a:t>
+            </a:r>
+            <a:r>
+              <a:rPr lang="hu-HU" sz="2400" dirty="0"/>
+              <a:t>: </a:t>
+            </a:r>
+            <a:r>
+              <a:rPr lang="en-US" sz="2400" dirty="0"/>
+              <a:t>A </a:t>
+            </a:r>
+            <a:r>
+              <a:rPr lang="en-US" sz="2400" dirty="0" err="1"/>
+              <a:t>weboldal</a:t>
+            </a:r>
+            <a:r>
+              <a:rPr lang="en-US" sz="2400" dirty="0"/>
+              <a:t> </a:t>
+            </a:r>
+            <a:r>
+              <a:rPr lang="en-US" sz="2400" dirty="0" err="1"/>
+              <a:t>megjelenítését</a:t>
+            </a:r>
+            <a:r>
+              <a:rPr lang="en-US" sz="2400" dirty="0"/>
+              <a:t> </a:t>
+            </a:r>
+            <a:r>
+              <a:rPr lang="en-US" sz="2400" dirty="0" err="1"/>
+              <a:t>szabályozza</a:t>
+            </a:r>
+            <a:r>
+              <a:rPr lang="en-US" sz="2400" dirty="0"/>
+              <a:t> </a:t>
+            </a:r>
+            <a:r>
+              <a:rPr lang="en-US" sz="2400" dirty="0" err="1"/>
+              <a:t>mobil</a:t>
+            </a:r>
+            <a:r>
+              <a:rPr lang="en-US" sz="2400" dirty="0"/>
+              <a:t> </a:t>
+            </a:r>
+            <a:r>
+              <a:rPr lang="en-US" sz="2400" dirty="0" err="1"/>
+              <a:t>eszközökön</a:t>
+            </a:r>
+            <a:endParaRPr kumimoji="0" lang="en-US" altLang="en-US" sz="2200" i="0" u="none" strike="noStrike" cap="none" normalizeH="0" baseline="0" dirty="0">
               <a:ln>
                 <a:noFill/>
               </a:ln>
@@ -13342,7 +13911,7 @@
         </p:nvSpPr>
         <p:spPr>
           <a:xfrm>
-            <a:off x="481707" y="5221686"/>
+            <a:off x="518160" y="5107149"/>
             <a:ext cx="10676288" cy="400110"/>
           </a:xfrm>
           <a:prstGeom prst="rect">
@@ -13391,6 +13960,36 @@
           </a:p>
         </p:txBody>
       </p:sp>
+      <p:pic>
+        <p:nvPicPr>
+          <p:cNvPr id="4" name="Picture 3">
+            <a:extLst>
+              <a:ext uri="{FF2B5EF4-FFF2-40B4-BE49-F238E27FC236}">
+                <a16:creationId xmlns:a16="http://schemas.microsoft.com/office/drawing/2014/main" id="{9A486D1F-AC01-C82C-AABC-AE88FF23010E}"/>
+              </a:ext>
+            </a:extLst>
+          </p:cNvPr>
+          <p:cNvPicPr>
+            <a:picLocks noChangeAspect="1"/>
+          </p:cNvPicPr>
+          <p:nvPr/>
+        </p:nvPicPr>
+        <p:blipFill>
+          <a:blip r:embed="rId4"/>
+          <a:stretch>
+            <a:fillRect/>
+          </a:stretch>
+        </p:blipFill>
+        <p:spPr>
+          <a:xfrm>
+            <a:off x="518160" y="5942346"/>
+            <a:ext cx="6827185" cy="346935"/>
+          </a:xfrm>
+          <a:prstGeom prst="rect">
+            <a:avLst/>
+          </a:prstGeom>
+        </p:spPr>
+      </p:pic>
     </p:spTree>
     <p:extLst>
       <p:ext uri="{BB962C8B-B14F-4D97-AF65-F5344CB8AC3E}">

</xml_diff>